<commit_message>
Attach reviewed PDFs PPTX files and all 36 slide renders
</commit_message>
<xml_diff>
--- a/output/pptx/ocean-company-leadership-overview.pptx
+++ b/output/pptx/ocean-company-leadership-overview.pptx
@@ -1678,7 +1678,7 @@
       </p:grpSpPr>
       <p:pic>
         <p:nvPicPr>
-          <p:cNvPr id="2" name="ocean:environment" descr="C:\Users\sctho\OneDrive\Documents\ChatGPT\ocean-brand-system\assets\environments\env_sage_map_dark.jpg">    </p:cNvPr>
+          <p:cNvPr id="2" name="ocean:environment" descr="/home/runner/work/ocean-brand-system/ocean-brand-system/assets/environments/env_sage_map_dark.jpg">    </p:cNvPr>
           <p:cNvPicPr>
             <a:picLocks noChangeAspect="1"/>
           </p:cNvPicPr>
@@ -1760,7 +1760,7 @@
       </p:sp>
       <p:pic>
         <p:nvPicPr>
-          <p:cNvPr id="5" name="ocean:logo-vertical" descr="C:\Users\sctho\OneDrive\Documents\ChatGPT\ocean-brand-system\assets\logos\png\logo_vertical_honeydew.png">    </p:cNvPr>
+          <p:cNvPr id="5" name="ocean:logo-vertical" descr="/home/runner/work/ocean-brand-system/ocean-brand-system/assets/logos/png/logo_vertical_honeydew.png">    </p:cNvPr>
           <p:cNvPicPr>
             <a:picLocks noChangeAspect="1"/>
           </p:cNvPicPr>
@@ -2237,7 +2237,7 @@
       </p:grpSpPr>
       <p:pic>
         <p:nvPicPr>
-          <p:cNvPr id="2" name="ocean:environment" descr="C:\Users\sctho\OneDrive\Documents\ChatGPT\ocean-brand-system\assets\environments\env_sage_map_dark.jpg">    </p:cNvPr>
+          <p:cNvPr id="2" name="ocean:environment" descr="/home/runner/work/ocean-brand-system/ocean-brand-system/assets/environments/env_sage_map_dark.jpg">    </p:cNvPr>
           <p:cNvPicPr>
             <a:picLocks noChangeAspect="1"/>
           </p:cNvPicPr>
@@ -2261,7 +2261,7 @@
       </p:pic>
       <p:pic>
         <p:nvPicPr>
-          <p:cNvPr id="3" name="ocean:logo-vertical" descr="C:\Users\sctho\OneDrive\Documents\ChatGPT\ocean-brand-system\assets\logos\png\logo_vertical_honeydew.png">    </p:cNvPr>
+          <p:cNvPr id="3" name="ocean:logo-vertical" descr="/home/runner/work/ocean-brand-system/ocean-brand-system/assets/logos/png/logo_vertical_honeydew.png">    </p:cNvPr>
           <p:cNvPicPr>
             <a:picLocks noChangeAspect="1"/>
           </p:cNvPicPr>
@@ -2317,7 +2317,7 @@
       </p:grpSpPr>
       <p:pic>
         <p:nvPicPr>
-          <p:cNvPr id="2" name="ocean:logo-horizontal" descr="C:\Users\sctho\OneDrive\Documents\ChatGPT\ocean-brand-system\assets\logos\png\logo_horizontal_blackmoss.png">    </p:cNvPr>
+          <p:cNvPr id="2" name="ocean:logo-horizontal" descr="/home/runner/work/ocean-brand-system/ocean-brand-system/assets/logos/png/logo_horizontal_blackmoss.png">    </p:cNvPr>
           <p:cNvPicPr>
             <a:picLocks noChangeAspect="1"/>
           </p:cNvPicPr>
@@ -3207,7 +3207,7 @@
       </p:sp>
       <p:pic>
         <p:nvPicPr>
-          <p:cNvPr id="4" name="ocean:logo-horizontal" descr="C:\Users\sctho\OneDrive\Documents\ChatGPT\ocean-brand-system\assets\logos\png\logo_horizontal_peacock.png">    </p:cNvPr>
+          <p:cNvPr id="4" name="ocean:logo-horizontal" descr="/home/runner/work/ocean-brand-system/ocean-brand-system/assets/logos/png/logo_horizontal_peacock.png">    </p:cNvPr>
           <p:cNvPicPr>
             <a:picLocks noChangeAspect="1"/>
           </p:cNvPicPr>
@@ -4135,7 +4135,7 @@
       </p:sp>
       <p:pic>
         <p:nvPicPr>
-          <p:cNvPr id="30" name="ocean:photo" descr="C:\Users\sctho\OneDrive\Documents\ChatGPT\ocean-brand-system\output\.cache\fit\solar-carport-campus-041d77b11b2a487a.jpg">    </p:cNvPr>
+          <p:cNvPr id="30" name="ocean:photo" descr="/home/runner/work/ocean-brand-system/ocean-brand-system/output/.cache/fit/solar-carport-campus-643b6b4ed5e83ee1.jpg">    </p:cNvPr>
           <p:cNvPicPr>
             <a:picLocks noChangeAspect="1"/>
           </p:cNvPicPr>
@@ -5152,7 +5152,7 @@
       </p:sp>
       <p:pic>
         <p:nvPicPr>
-          <p:cNvPr id="4" name="ocean:logo-horizontal" descr="C:\Users\sctho\OneDrive\Documents\ChatGPT\ocean-brand-system\assets\logos\png\logo_horizontal_peacock.png">    </p:cNvPr>
+          <p:cNvPr id="4" name="ocean:logo-horizontal" descr="/home/runner/work/ocean-brand-system/ocean-brand-system/assets/logos/png/logo_horizontal_peacock.png">    </p:cNvPr>
           <p:cNvPicPr>
             <a:picLocks noChangeAspect="1"/>
           </p:cNvPicPr>
@@ -6967,7 +6967,7 @@
       </p:sp>
       <p:pic>
         <p:nvPicPr>
-          <p:cNvPr id="4" name="ocean:logo-horizontal" descr="C:\Users\sctho\OneDrive\Documents\ChatGPT\ocean-brand-system\assets\logos\png\logo_horizontal_cedar.png">    </p:cNvPr>
+          <p:cNvPr id="4" name="ocean:logo-horizontal" descr="/home/runner/work/ocean-brand-system/ocean-brand-system/assets/logos/png/logo_horizontal_cedar.png">    </p:cNvPr>
           <p:cNvPicPr>
             <a:picLocks noChangeAspect="1"/>
           </p:cNvPicPr>
@@ -8656,7 +8656,7 @@
       </p:sp>
       <p:pic>
         <p:nvPicPr>
-          <p:cNvPr id="4" name="ocean:logo-horizontal" descr="C:\Users\sctho\OneDrive\Documents\ChatGPT\ocean-brand-system\assets\logos\png\logo_horizontal_cedar.png">    </p:cNvPr>
+          <p:cNvPr id="4" name="ocean:logo-horizontal" descr="/home/runner/work/ocean-brand-system/ocean-brand-system/assets/logos/png/logo_horizontal_cedar.png">    </p:cNvPr>
           <p:cNvPicPr>
             <a:picLocks noChangeAspect="1"/>
           </p:cNvPicPr>
@@ -9584,7 +9584,7 @@
       </p:sp>
       <p:pic>
         <p:nvPicPr>
-          <p:cNvPr id="30" name="ocean:photo" descr="C:\Users\sctho\OneDrive\Documents\ChatGPT\ocean-brand-system\output\.cache\fit\solar-carport-campus-507998c14047a968.jpg">    </p:cNvPr>
+          <p:cNvPr id="30" name="ocean:photo" descr="/home/runner/work/ocean-brand-system/ocean-brand-system/output/.cache/fit/solar-carport-campus-ff22483aa15a91bf.jpg">    </p:cNvPr>
           <p:cNvPicPr>
             <a:picLocks noChangeAspect="1"/>
           </p:cNvPicPr>
@@ -10356,7 +10356,7 @@
       </p:sp>
       <p:pic>
         <p:nvPicPr>
-          <p:cNvPr id="4" name="ocean:logo-horizontal" descr="C:\Users\sctho\OneDrive\Documents\ChatGPT\ocean-brand-system\assets\logos\png\logo_horizontal_olive.png">    </p:cNvPr>
+          <p:cNvPr id="4" name="ocean:logo-horizontal" descr="/home/runner/work/ocean-brand-system/ocean-brand-system/assets/logos/png/logo_horizontal_olive.png">    </p:cNvPr>
           <p:cNvPicPr>
             <a:picLocks noChangeAspect="1"/>
           </p:cNvPicPr>
@@ -12040,7 +12040,7 @@
       </p:grpSpPr>
       <p:pic>
         <p:nvPicPr>
-          <p:cNvPr id="2" name="ocean:texture" descr="C:\Users\sctho\OneDrive\Documents\ChatGPT\ocean-brand-system\assets\textures\tex_deck_blackmoss.png">    </p:cNvPr>
+          <p:cNvPr id="2" name="ocean:texture" descr="/home/runner/work/ocean-brand-system/ocean-brand-system/assets/textures/tex_deck_blackmoss.png">    </p:cNvPr>
           <p:cNvPicPr>
             <a:picLocks noChangeAspect="1"/>
           </p:cNvPicPr>
@@ -12064,7 +12064,7 @@
       </p:pic>
       <p:pic>
         <p:nvPicPr>
-          <p:cNvPr id="4" name="ocean:logo-graphic" descr="C:\Users\sctho\OneDrive\Documents\ChatGPT\ocean-brand-system\assets\logos\png\logo_graphic_honeydew.png">    </p:cNvPr>
+          <p:cNvPr id="4" name="ocean:logo-graphic" descr="/home/runner/work/ocean-brand-system/ocean-brand-system/assets/logos/png/logo_graphic_honeydew.png">    </p:cNvPr>
           <p:cNvPicPr>
             <a:picLocks noChangeAspect="1"/>
           </p:cNvPicPr>
@@ -12521,7 +12521,7 @@
       </p:sp>
       <p:pic>
         <p:nvPicPr>
-          <p:cNvPr id="4" name="ocean:logo-horizontal" descr="C:\Users\sctho\OneDrive\Documents\ChatGPT\ocean-brand-system\assets\logos\png\logo_horizontal_blackmoss.png">    </p:cNvPr>
+          <p:cNvPr id="4" name="ocean:logo-horizontal" descr="/home/runner/work/ocean-brand-system/ocean-brand-system/assets/logos/png/logo_horizontal_blackmoss.png">    </p:cNvPr>
           <p:cNvPicPr>
             <a:picLocks noChangeAspect="1"/>
           </p:cNvPicPr>

</xml_diff>